<commit_message>
feat(diagrams,slides): enforce Rule 53G per-pattern Slide 5 topology across WS1-WS5 and sync 15/15 Google Slides
</commit_message>
<xml_diff>
--- a/slides/doc-ref-07-editable-slides.pptx
+++ b/slides/doc-ref-07-editable-slides.pptx
@@ -507,7 +507,21 @@
           <a:p>
             <a:r>
               <a:rPr lang="en-US" dirty="0"/>
-              <a:t/>
+              <a:t>Welcome everyone. In this six-slide executive and technical briefing, we are walking through Multimodal GraphRAG Resource Orchestration with Spanner Graph &amp; Vertex AI.</a:t>
+            </a:r>
+            <a:endParaRPr lang="en-US" dirty="0"/>
+          </a:p>
+          <a:p>
+            <a:r>
+              <a:rPr lang="en-US" dirty="0"/>
+              <a:t>In this briefing, we are looking at how to combine knowledge graphs and vector search inside a single Google Cloud Spanner Graph database—allowing AI agents to reason accurately across complex multi-hop relationships like supply chains, financial networks, and clinical pathways alongside documents, images, and audio.</a:t>
+            </a:r>
+            <a:endParaRPr lang="en-US" dirty="0"/>
+          </a:p>
+          <a:p>
+            <a:r>
+              <a:rPr lang="en-US" dirty="0"/>
+              <a:t>With our business goal and architectural thesis set, let's turn to Slide 2 to examine the complete Figure 1 Google Cloud Hub-and-Spoke blueprint.</a:t>
             </a:r>
             <a:endParaRPr lang="en-US" dirty="0"/>
           </a:p>
@@ -595,7 +609,21 @@
           <a:p>
             <a:r>
               <a:rPr lang="en-US" dirty="0"/>
-              <a:t/>
+              <a:t>Building on the executive overview we just covered on Slide 1, this diagram gives us the complete end-to-end physical map of the system on Google Cloud.</a:t>
+            </a:r>
+            <a:endParaRPr lang="en-US" dirty="0"/>
+          </a:p>
+          <a:p>
+            <a:r>
+              <a:rPr lang="en-US" dirty="0"/>
+              <a:t>Here in Figure 1 is our complete Google Cloud physical blueprint. User queries enter through the blue Routing Hub via Cloud Armor and Identity-Aware Proxy, get orchestrated by our ADK 2.0 Reasoning Agent in the green Governance Hub, and execute combined graph-traversal and vector-similarity queries inside Spanner Graph and Vertex AI across the bottom execution spokes.</a:t>
+            </a:r>
+            <a:endParaRPr lang="en-US" dirty="0"/>
+          </a:p>
+          <a:p>
+            <a:r>
+              <a:rPr lang="en-US" dirty="0"/>
+              <a:t>Now that we see where each component sits in Figure 1, let's move to Slide 3 to walk through how a live request flows across these services step by step.</a:t>
             </a:r>
             <a:endParaRPr lang="en-US" dirty="0"/>
           </a:p>
@@ -683,7 +711,21 @@
           <a:p>
             <a:r>
               <a:rPr lang="en-US" dirty="0"/>
-              <a:t/>
+              <a:t>Taking the physical components from the Figure 1 blueprint on Slide 2, this slide unpacks the exact step-by-step runtime workflow.</a:t>
+            </a:r>
+            <a:endParaRPr lang="en-US" dirty="0"/>
+          </a:p>
+          <a:p>
+            <a:r>
+              <a:rPr lang="en-US" dirty="0"/>
+              <a:t>Walking through the six steps on this slide shows why combining graph and vector retrieval is so powerful in practice. Unstructured files arriving in Cloud Storage are parsed into multimodal embeddings by Vertex AI and linked as typed nodes and edges inside Spanner Graph—so when a user asks a complex question, the agent retrieves both semantic matches and exact multi-hop relationship chains in one transaction.</a:t>
+            </a:r>
+            <a:endParaRPr lang="en-US" dirty="0"/>
+          </a:p>
+          <a:p>
+            <a:r>
+              <a:rPr lang="en-US" dirty="0"/>
+              <a:t>Having seen how the components interact step by step on Slide 3, let's turn to Slide 4 to see how this architecture solves a concrete enterprise customer use case.</a:t>
             </a:r>
             <a:endParaRPr lang="en-US" dirty="0"/>
           </a:p>
@@ -771,7 +813,21 @@
           <a:p>
             <a:r>
               <a:rPr lang="en-US" dirty="0"/>
-              <a:t/>
+              <a:t>Following our step-by-step technical workflow on Slide 3, this slide connects the architecture directly to tangible business value and the managed Google Cloud services that power it.</a:t>
+            </a:r>
+            <a:endParaRPr lang="en-US" dirty="0"/>
+          </a:p>
+          <a:p>
+            <a:r>
+              <a:rPr lang="en-US" dirty="0"/>
+              <a:t>This slide connects that technical workflow to a concrete business outcome. Standard vector-only RAG often fails when an answer depends on connecting three or four indirect entities across different documents; by unifying GQL graph traversal and cosine vector search inside Spanner Graph, enterprise teams eliminate hallucinations while avoiding the operational cost of syncing separate graph and vector databases.</a:t>
+            </a:r>
+            <a:endParaRPr lang="en-US" dirty="0"/>
+          </a:p>
+          <a:p>
+            <a:r>
+              <a:rPr lang="en-US" dirty="0"/>
+              <a:t>Once business and technical leaders see how the use case works on Slide 4, the natural next question is: how does this compare to alternative designs, and what are the trade-offs? Let's look at Slide 5.</a:t>
             </a:r>
             <a:endParaRPr lang="en-US" dirty="0"/>
           </a:p>
@@ -859,7 +915,21 @@
           <a:p>
             <a:r>
               <a:rPr lang="en-US" dirty="0"/>
-              <a:t/>
+              <a:t>Building on the customer use case from Slide 4, this slide evaluates our architectural trade-offs so decision-makers have full confidence in why this design is recommended.</a:t>
+            </a:r>
+            <a:endParaRPr lang="en-US" dirty="0"/>
+          </a:p>
+          <a:p>
+            <a:r>
+              <a:rPr lang="en-US" dirty="0"/>
+              <a:t>Here we compare our unified Spanner Graph architecture against stitching together standalone graph and vector databases across latency, consistency, and operational overhead. The takeaway for decision-makers is simple: running graph and vector search inside one transactional engine removes dual-write drift and cuts multi-hop query latency significantly.</a:t>
+            </a:r>
+            <a:endParaRPr lang="en-US" dirty="0"/>
+          </a:p>
+          <a:p>
+            <a:r>
+              <a:rPr lang="en-US" dirty="0"/>
+              <a:t>With the architectural trade-offs clear here on Slide 5, let's turn to our final slide—Slide 6—to walk through the deployment checklist and next steps.</a:t>
             </a:r>
             <a:endParaRPr lang="en-US" dirty="0"/>
           </a:p>
@@ -947,7 +1017,21 @@
           <a:p>
             <a:r>
               <a:rPr lang="en-US" dirty="0"/>
-              <a:t/>
+              <a:t>Rounding out the design trade-offs from Slide 5, our closing slide transitions from architecture into hands-on production deployment.</a:t>
+            </a:r>
+            <a:endParaRPr lang="en-US" dirty="0"/>
+          </a:p>
+          <a:p>
+            <a:r>
+              <a:rPr lang="en-US" dirty="0"/>
+              <a:t>Finally, here is the practical deployment checklist and runnable schema setup so your engineering team can provision Spanner Graph and Vertex AI embeddings today.</a:t>
+            </a:r>
+            <a:endParaRPr lang="en-US" dirty="0"/>
+          </a:p>
+          <a:p>
+            <a:r>
+              <a:rPr lang="en-US" dirty="0"/>
+              <a:t>That concludes our six-slide briefing—let's open the floor for your questions or launch the interactive codebase workbench to inspect the implementation files directly.</a:t>
             </a:r>
             <a:endParaRPr lang="en-US" dirty="0"/>
           </a:p>

</xml_diff>

<commit_message>
chore(forensic-audit): sync 15 distinct Google Slides, 6 Rule-49 Docs, 14 diagrams, 27-file bundle & ge-blogs-00024-ng7
</commit_message>
<xml_diff>
--- a/slides/doc-ref-07-editable-slides.pptx
+++ b/slides/doc-ref-07-editable-slides.pptx
@@ -2546,7 +2546,7 @@
               <a:buNone/>
             </a:pPr>
             <a:r>
-              <a:rPr lang="en-US" sz="450" dirty="0">
+              <a:rPr lang="en-US" sz="450" b="1" dirty="0">
                 <a:solidFill>
                   <a:srgbClr val="202124"/>
                 </a:solidFill>
@@ -2637,7 +2637,7 @@
               <a:buNone/>
             </a:pPr>
             <a:r>
-              <a:rPr lang="en-US" sz="450" dirty="0">
+              <a:rPr lang="en-US" sz="450" b="1" dirty="0">
                 <a:solidFill>
                   <a:srgbClr val="202124"/>
                 </a:solidFill>
@@ -2728,7 +2728,7 @@
               <a:buNone/>
             </a:pPr>
             <a:r>
-              <a:rPr lang="en-US" sz="410" dirty="0">
+              <a:rPr lang="en-US" sz="410" b="1" dirty="0">
                 <a:solidFill>
                   <a:srgbClr val="202124"/>
                 </a:solidFill>

</xml_diff>